<commit_message>
chore(ooad,ai-native): re-render decks for the new block rhythm
간격 변경으로 쪽 배분이 달라진 세션을 다시 렌더링한다. OOAD S01의 「거절 뒤 상태 유지
테스트」는 설명 bullet 둘을 하나로 합쳐 빈 연속 슬라이드를 없앴다.

Co-Authored-By: Claude Fable 5 <noreply@anthropic.com>
</commit_message>
<xml_diff>
--- a/courses/ai-native/sessions/s01.pptx
+++ b/courses/ai-native/sessions/s01.pptx
@@ -3964,7 +3964,7 @@
           </p:nvPr>
         </p:nvGraphicFramePr>
         <p:xfrm>
-          <a:off x="921575" y="3099498"/>
+          <a:off x="921575" y="2898948"/>
           <a:ext cx="7287260" cy="3873500"/>
         </p:xfrm>
         <a:graphic>
@@ -4464,7 +4464,7 @@
         <p:spPr>
           <a:xfrm>
             <a:off x="365760" y="960120"/>
-            <a:ext cx="8412480" cy="1739328"/>
+            <a:ext cx="8412480" cy="1587442"/>
           </a:xfrm>
           <a:prstGeom prst="rect">
             <a:avLst/>
@@ -4671,7 +4671,7 @@
         </p:nvSpPr>
         <p:spPr>
           <a:xfrm>
-            <a:off x="365760" y="2801048"/>
+            <a:off x="365760" y="2600498"/>
             <a:ext cx="8412480" cy="222250"/>
           </a:xfrm>
           <a:prstGeom prst="rect">
@@ -4720,7 +4720,7 @@
         </p:nvSpPr>
         <p:spPr>
           <a:xfrm>
-            <a:off x="365760" y="4353098"/>
+            <a:off x="365760" y="4279548"/>
             <a:ext cx="8412480" cy="781278"/>
           </a:xfrm>
           <a:prstGeom prst="rect">
@@ -5950,7 +5950,7 @@
           </p:nvPr>
         </p:nvGraphicFramePr>
         <p:xfrm>
-          <a:off x="1480375" y="3099498"/>
+          <a:off x="1480375" y="2898948"/>
           <a:ext cx="6169660" cy="3873500"/>
         </p:xfrm>
         <a:graphic>
@@ -6450,7 +6450,7 @@
         <p:spPr>
           <a:xfrm>
             <a:off x="365760" y="960120"/>
-            <a:ext cx="8412480" cy="1739328"/>
+            <a:ext cx="8412480" cy="1587442"/>
           </a:xfrm>
           <a:prstGeom prst="rect">
             <a:avLst/>
@@ -6687,7 +6687,7 @@
         </p:nvSpPr>
         <p:spPr>
           <a:xfrm>
-            <a:off x="365760" y="2801048"/>
+            <a:off x="365760" y="2600498"/>
             <a:ext cx="8412480" cy="222250"/>
           </a:xfrm>
           <a:prstGeom prst="rect">
@@ -6736,7 +6736,7 @@
         </p:nvSpPr>
         <p:spPr>
           <a:xfrm>
-            <a:off x="365760" y="4353098"/>
+            <a:off x="365760" y="4279548"/>
             <a:ext cx="8412480" cy="781278"/>
           </a:xfrm>
           <a:prstGeom prst="rect">
@@ -7159,8 +7159,8 @@
         </p:nvSpPr>
         <p:spPr>
           <a:xfrm>
-            <a:off x="365760" y="4316622"/>
-            <a:ext cx="8412480" cy="274320"/>
+            <a:off x="365760" y="3136392"/>
+            <a:ext cx="8412480" cy="201168"/>
           </a:xfrm>
           <a:prstGeom prst="rect">
             <a:avLst/>
@@ -7203,7 +7203,7 @@
         </p:blipFill>
         <p:spPr>
           <a:xfrm>
-            <a:off x="1056298" y="4590942"/>
+            <a:off x="1056298" y="3374136"/>
             <a:ext cx="7031404" cy="1123462"/>
           </a:xfrm>
           <a:prstGeom prst="rect">
@@ -7392,7 +7392,7 @@
           </p:nvPr>
         </p:nvGraphicFramePr>
         <p:xfrm>
-          <a:off x="1663256" y="3344852"/>
+          <a:off x="1663256" y="3249468"/>
           <a:ext cx="5803900" cy="3873500"/>
         </p:xfrm>
         <a:graphic>
@@ -8391,7 +8391,7 @@
         </p:nvSpPr>
         <p:spPr>
           <a:xfrm>
-            <a:off x="365760" y="3046402"/>
+            <a:off x="365760" y="2951018"/>
             <a:ext cx="8412480" cy="222250"/>
           </a:xfrm>
           <a:prstGeom prst="rect">
@@ -8440,7 +8440,7 @@
         </p:nvSpPr>
         <p:spPr>
           <a:xfrm>
-            <a:off x="365760" y="4598452"/>
+            <a:off x="365760" y="4630068"/>
             <a:ext cx="8412480" cy="781278"/>
           </a:xfrm>
           <a:prstGeom prst="rect">
@@ -8679,7 +8679,7 @@
           </p:nvPr>
         </p:nvGraphicFramePr>
         <p:xfrm>
-          <a:off x="412306" y="2141448"/>
+          <a:off x="412306" y="2112010"/>
           <a:ext cx="8305800" cy="3873500"/>
         </p:xfrm>
         <a:graphic>
@@ -9791,7 +9791,7 @@
         </p:nvSpPr>
         <p:spPr>
           <a:xfrm>
-            <a:off x="365760" y="1842998"/>
+            <a:off x="365760" y="1813560"/>
             <a:ext cx="8412480" cy="222250"/>
           </a:xfrm>
           <a:prstGeom prst="rect">
@@ -9840,7 +9840,7 @@
         </p:nvSpPr>
         <p:spPr>
           <a:xfrm>
-            <a:off x="365760" y="3395048"/>
+            <a:off x="365760" y="3492610"/>
             <a:ext cx="8412480" cy="2089833"/>
           </a:xfrm>
           <a:prstGeom prst="rect">
@@ -10392,8 +10392,8 @@
         </p:nvSpPr>
         <p:spPr>
           <a:xfrm>
-            <a:off x="365760" y="3919503"/>
-            <a:ext cx="8412480" cy="274320"/>
+            <a:off x="365760" y="2938272"/>
+            <a:ext cx="8412480" cy="201168"/>
           </a:xfrm>
           <a:prstGeom prst="rect">
             <a:avLst/>
@@ -10436,7 +10436,7 @@
         </p:blipFill>
         <p:spPr>
           <a:xfrm>
-            <a:off x="1460500" y="4193822"/>
+            <a:off x="1460500" y="3176016"/>
             <a:ext cx="6223000" cy="1778000"/>
           </a:xfrm>
           <a:prstGeom prst="rect">
@@ -10872,8 +10872,8 @@
         </p:nvSpPr>
         <p:spPr>
           <a:xfrm>
-            <a:off x="365760" y="4407035"/>
-            <a:ext cx="8412480" cy="274320"/>
+            <a:off x="365760" y="4035552"/>
+            <a:ext cx="8412480" cy="201168"/>
           </a:xfrm>
           <a:prstGeom prst="rect">
             <a:avLst/>
@@ -10916,7 +10916,7 @@
         </p:blipFill>
         <p:spPr>
           <a:xfrm>
-            <a:off x="1460500" y="4681355"/>
+            <a:off x="1460500" y="4273296"/>
             <a:ext cx="6223000" cy="674688"/>
           </a:xfrm>
           <a:prstGeom prst="rect">
@@ -13307,7 +13307,7 @@
           </p:nvPr>
         </p:nvGraphicFramePr>
         <p:xfrm>
-          <a:off x="783146" y="2141448"/>
+          <a:off x="783146" y="2112010"/>
           <a:ext cx="7564120" cy="3873500"/>
         </p:xfrm>
         <a:graphic>
@@ -15060,7 +15060,7 @@
         </p:nvSpPr>
         <p:spPr>
           <a:xfrm>
-            <a:off x="365760" y="1842998"/>
+            <a:off x="365760" y="1813560"/>
             <a:ext cx="8412480" cy="222250"/>
           </a:xfrm>
           <a:prstGeom prst="rect">
@@ -15109,7 +15109,7 @@
         </p:nvSpPr>
         <p:spPr>
           <a:xfrm>
-            <a:off x="365760" y="4835048"/>
+            <a:off x="365760" y="4932610"/>
             <a:ext cx="8412480" cy="781278"/>
           </a:xfrm>
           <a:prstGeom prst="rect">
@@ -15615,8 +15615,8 @@
         </p:nvSpPr>
         <p:spPr>
           <a:xfrm>
-            <a:off x="365760" y="4133166"/>
-            <a:ext cx="8412480" cy="274320"/>
+            <a:off x="365760" y="3649010"/>
+            <a:ext cx="8412480" cy="201168"/>
           </a:xfrm>
           <a:prstGeom prst="rect">
             <a:avLst/>
@@ -15659,7 +15659,7 @@
         </p:blipFill>
         <p:spPr>
           <a:xfrm>
-            <a:off x="1460500" y="4407486"/>
+            <a:off x="1460500" y="3886754"/>
             <a:ext cx="6223000" cy="960437"/>
           </a:xfrm>
           <a:prstGeom prst="rect">
@@ -15836,7 +15836,7 @@
           </p:nvPr>
         </p:nvGraphicFramePr>
         <p:xfrm>
-          <a:off x="412306" y="2141448"/>
+          <a:off x="412306" y="2112010"/>
           <a:ext cx="8305800" cy="3873500"/>
         </p:xfrm>
         <a:graphic>
@@ -17620,7 +17620,7 @@
         </p:nvSpPr>
         <p:spPr>
           <a:xfrm>
-            <a:off x="365760" y="1842998"/>
+            <a:off x="365760" y="1813560"/>
             <a:ext cx="8412480" cy="222250"/>
           </a:xfrm>
           <a:prstGeom prst="rect">
@@ -20445,8 +20445,8 @@
         </p:nvSpPr>
         <p:spPr>
           <a:xfrm>
-            <a:off x="365760" y="3858860"/>
-            <a:ext cx="8412480" cy="274320"/>
+            <a:off x="365760" y="3212592"/>
+            <a:ext cx="8412480" cy="201168"/>
           </a:xfrm>
           <a:prstGeom prst="rect">
             <a:avLst/>
@@ -20489,7 +20489,7 @@
         </p:blipFill>
         <p:spPr>
           <a:xfrm>
-            <a:off x="1944688" y="4133180"/>
+            <a:off x="1944688" y="3450336"/>
             <a:ext cx="5254625" cy="2206625"/>
           </a:xfrm>
           <a:prstGeom prst="rect">
@@ -21090,7 +21090,7 @@
           </p:nvPr>
         </p:nvGraphicFramePr>
         <p:xfrm>
-          <a:off x="412306" y="2141448"/>
+          <a:off x="412306" y="2112010"/>
           <a:ext cx="8305800" cy="3873500"/>
         </p:xfrm>
         <a:graphic>
@@ -21963,7 +21963,7 @@
         </p:nvSpPr>
         <p:spPr>
           <a:xfrm>
-            <a:off x="365760" y="1842998"/>
+            <a:off x="365760" y="1813560"/>
             <a:ext cx="8412480" cy="222250"/>
           </a:xfrm>
           <a:prstGeom prst="rect">
@@ -22012,7 +22012,7 @@
         </p:nvSpPr>
         <p:spPr>
           <a:xfrm>
-            <a:off x="365760" y="3395048"/>
+            <a:off x="365760" y="3492610"/>
             <a:ext cx="8412480" cy="781278"/>
           </a:xfrm>
           <a:prstGeom prst="rect">
@@ -22532,8 +22532,8 @@
         </p:nvSpPr>
         <p:spPr>
           <a:xfrm>
-            <a:off x="365760" y="3257832"/>
-            <a:ext cx="8412480" cy="274320"/>
+            <a:off x="365760" y="2663952"/>
+            <a:ext cx="8412480" cy="201168"/>
           </a:xfrm>
           <a:prstGeom prst="rect">
             <a:avLst/>
@@ -22576,7 +22576,7 @@
         </p:blipFill>
         <p:spPr>
           <a:xfrm>
-            <a:off x="1024548" y="3532152"/>
+            <a:off x="1024548" y="2901696"/>
             <a:ext cx="7094904" cy="2794000"/>
           </a:xfrm>
           <a:prstGeom prst="rect">
@@ -23447,7 +23447,7 @@
           </p:nvPr>
         </p:nvGraphicFramePr>
         <p:xfrm>
-          <a:off x="1635316" y="3778033"/>
+          <a:off x="1635316" y="3912172"/>
           <a:ext cx="5859780" cy="3873500"/>
         </p:xfrm>
         <a:graphic>
@@ -24320,7 +24320,7 @@
         </p:nvSpPr>
         <p:spPr>
           <a:xfrm>
-            <a:off x="365760" y="3479583"/>
+            <a:off x="365760" y="3613722"/>
             <a:ext cx="8412480" cy="222250"/>
           </a:xfrm>
           <a:prstGeom prst="rect">
@@ -24369,8 +24369,8 @@
         </p:nvSpPr>
         <p:spPr>
           <a:xfrm>
-            <a:off x="365760" y="1842998"/>
-            <a:ext cx="8412480" cy="274320"/>
+            <a:off x="365760" y="1886712"/>
+            <a:ext cx="8412480" cy="201168"/>
           </a:xfrm>
           <a:prstGeom prst="rect">
             <a:avLst/>
@@ -24420,7 +24420,7 @@
         </p:blipFill>
         <p:spPr>
           <a:xfrm>
-            <a:off x="1453706" y="2117318"/>
+            <a:off x="1453706" y="2124456"/>
             <a:ext cx="6223000" cy="1150938"/>
           </a:xfrm>
           <a:prstGeom prst="rect">
@@ -24609,7 +24609,7 @@
           </p:nvPr>
         </p:nvGraphicFramePr>
         <p:xfrm>
-          <a:off x="412306" y="2445220"/>
+          <a:off x="412306" y="2436206"/>
           <a:ext cx="8305800" cy="3873500"/>
         </p:xfrm>
         <a:graphic>
@@ -25374,7 +25374,7 @@
         </p:nvSpPr>
         <p:spPr>
           <a:xfrm>
-            <a:off x="365760" y="2146770"/>
+            <a:off x="365760" y="2137756"/>
             <a:ext cx="8412480" cy="222250"/>
           </a:xfrm>
           <a:prstGeom prst="rect">
@@ -25423,7 +25423,7 @@
         </p:nvSpPr>
         <p:spPr>
           <a:xfrm>
-            <a:off x="365760" y="3410820"/>
+            <a:off x="365760" y="3528806"/>
             <a:ext cx="8412480" cy="1178518"/>
           </a:xfrm>
           <a:prstGeom prst="rect">

</xml_diff>